<commit_message>
Update proposal figures and scripts for consolidated PPTX generation
- Replaced individual PPTX generation with a single consolidated PPTX file containing all figures.
- Updated `generate-individual-figures.js` to reflect the new output format and structure.
- Modified HTML slides for figures to use 'Malgun Gothic' font and translated text to Korean.
- Updated binary files for figures and the final proposal document.
</commit_message>
<xml_diff>
--- a/04-proposal/figures/fig-1-scheduling-comparison.pptx
+++ b/04-proposal/figures/fig-1-scheduling-comparison.pptx
@@ -884,7 +884,7 @@
         <p:spPr>
           <a:xfrm>
             <a:off x="381000" y="304800"/>
-            <a:ext cx="2000250" cy="3556695"/>
+            <a:ext cx="2000250" cy="3518595"/>
           </a:xfrm>
           <a:prstGeom prst="rect">
             <a:avLst/>
@@ -966,9 +966,9 @@
                 <a:solidFill>
                   <a:srgbClr val="FFFFFF"/>
                 </a:solidFill>
-                <a:latin typeface="Times New Roman" pitchFamily="34" charset="0"/>
-                <a:ea typeface="Times New Roman" pitchFamily="34" charset="-122"/>
-                <a:cs typeface="Times New Roman" pitchFamily="34" charset="-120"/>
+                <a:latin typeface="Malgun Gothic" pitchFamily="34" charset="0"/>
+                <a:ea typeface="Malgun Gothic" pitchFamily="34" charset="-122"/>
+                <a:cs typeface="Malgun Gothic" pitchFamily="34" charset="-120"/>
               </a:rPr>
               <a:t>FCFS</a:t>
             </a:r>
@@ -1011,11 +1011,11 @@
                 <a:solidFill>
                   <a:srgbClr val="555555"/>
                 </a:solidFill>
-                <a:latin typeface="Times New Roman" pitchFamily="34" charset="0"/>
-                <a:ea typeface="Times New Roman" pitchFamily="34" charset="-122"/>
-                <a:cs typeface="Times New Roman" pitchFamily="34" charset="-120"/>
-              </a:rPr>
-              <a:t>First-Come First-Served</a:t>
+                <a:latin typeface="Malgun Gothic" pitchFamily="34" charset="0"/>
+                <a:ea typeface="Malgun Gothic" pitchFamily="34" charset="-122"/>
+                <a:cs typeface="Malgun Gothic" pitchFamily="34" charset="-120"/>
+              </a:rPr>
+              <a:t>선착순 처리</a:t>
             </a:r>
             <a:endParaRPr lang="en-US" sz="900" dirty="0"/>
           </a:p>
@@ -1073,11 +1073,11 @@
                 <a:solidFill>
                   <a:srgbClr val="333333"/>
                 </a:solidFill>
-                <a:latin typeface="Times New Roman" pitchFamily="34" charset="0"/>
-                <a:ea typeface="Times New Roman" pitchFamily="34" charset="-122"/>
-                <a:cs typeface="Times New Roman" pitchFamily="34" charset="-120"/>
-              </a:rPr>
-              <a:t>Characteristics</a:t>
+                <a:latin typeface="Malgun Gothic" pitchFamily="34" charset="0"/>
+                <a:ea typeface="Malgun Gothic" pitchFamily="34" charset="-122"/>
+                <a:cs typeface="Malgun Gothic" pitchFamily="34" charset="-120"/>
+              </a:rPr>
+              <a:t>특징</a:t>
             </a:r>
             <a:endParaRPr lang="en-US" sz="900" dirty="0"/>
           </a:p>
@@ -1092,7 +1092,7 @@
         <p:spPr>
           <a:xfrm>
             <a:off x="517475" y="1383804"/>
-            <a:ext cx="1727299" cy="342900"/>
+            <a:ext cx="1727299" cy="400050"/>
           </a:xfrm>
           <a:prstGeom prst="rect">
             <a:avLst/>
@@ -1113,11 +1113,11 @@
                 <a:solidFill>
                   <a:srgbClr val="333333"/>
                 </a:solidFill>
-                <a:latin typeface="Times New Roman" pitchFamily="34" charset="0"/>
-                <a:ea typeface="Times New Roman" pitchFamily="34" charset="-122"/>
-                <a:cs typeface="Times New Roman" pitchFamily="34" charset="-120"/>
-              </a:rPr>
-              <a:t>Simple FIFO queue</a:t>
+                <a:latin typeface="Malgun Gothic" pitchFamily="34" charset="0"/>
+                <a:ea typeface="Malgun Gothic" pitchFamily="34" charset="-122"/>
+                <a:cs typeface="Malgun Gothic" pitchFamily="34" charset="-120"/>
+              </a:rPr>
+              <a:t>단순 FIFO 큐</a:t>
             </a:r>
             <a:endParaRPr lang="en-US" sz="850" dirty="0"/>
           </a:p>
@@ -1131,11 +1131,11 @@
                 <a:solidFill>
                   <a:srgbClr val="333333"/>
                 </a:solidFill>
-                <a:latin typeface="Times New Roman" pitchFamily="34" charset="0"/>
-                <a:ea typeface="Times New Roman" pitchFamily="34" charset="-122"/>
-                <a:cs typeface="Times New Roman" pitchFamily="34" charset="-120"/>
-              </a:rPr>
-              <a:t>Non-preemptive</a:t>
+                <a:latin typeface="Malgun Gothic" pitchFamily="34" charset="0"/>
+                <a:ea typeface="Malgun Gothic" pitchFamily="34" charset="-122"/>
+                <a:cs typeface="Malgun Gothic" pitchFamily="34" charset="-120"/>
+              </a:rPr>
+              <a:t>비선점형</a:t>
             </a:r>
             <a:endParaRPr lang="en-US" sz="850" dirty="0"/>
           </a:p>
@@ -1149,11 +1149,11 @@
                 <a:solidFill>
                   <a:srgbClr val="333333"/>
                 </a:solidFill>
-                <a:latin typeface="Times New Roman" pitchFamily="34" charset="0"/>
-                <a:ea typeface="Times New Roman" pitchFamily="34" charset="-122"/>
-                <a:cs typeface="Times New Roman" pitchFamily="34" charset="-120"/>
-              </a:rPr>
-              <a:t>O(1) scheduling</a:t>
+                <a:latin typeface="Malgun Gothic" pitchFamily="34" charset="0"/>
+                <a:ea typeface="Malgun Gothic" pitchFamily="34" charset="-122"/>
+                <a:cs typeface="Malgun Gothic" pitchFamily="34" charset="-120"/>
+              </a:rPr>
+              <a:t>O(1) 스케줄링</a:t>
             </a:r>
             <a:endParaRPr lang="en-US" sz="850" dirty="0"/>
           </a:p>
@@ -1167,7 +1167,7 @@
         </p:nvSpPr>
         <p:spPr>
           <a:xfrm>
-            <a:off x="517475" y="2039243"/>
+            <a:off x="517475" y="2096393"/>
             <a:ext cx="1727299" cy="0"/>
           </a:xfrm>
           <a:prstGeom prst="line">
@@ -1190,7 +1190,7 @@
         </p:nvSpPr>
         <p:spPr>
           <a:xfrm>
-            <a:off x="517475" y="1853505"/>
+            <a:off x="517475" y="1910655"/>
             <a:ext cx="1761845" cy="142875"/>
           </a:xfrm>
           <a:prstGeom prst="rect">
@@ -1211,11 +1211,11 @@
                 <a:solidFill>
                   <a:srgbClr val="333333"/>
                 </a:solidFill>
-                <a:latin typeface="Times New Roman" pitchFamily="34" charset="0"/>
-                <a:ea typeface="Times New Roman" pitchFamily="34" charset="-122"/>
-                <a:cs typeface="Times New Roman" pitchFamily="34" charset="-120"/>
-              </a:rPr>
-              <a:t>Limitation</a:t>
+                <a:latin typeface="Malgun Gothic" pitchFamily="34" charset="0"/>
+                <a:ea typeface="Malgun Gothic" pitchFamily="34" charset="-122"/>
+                <a:cs typeface="Malgun Gothic" pitchFamily="34" charset="-120"/>
+              </a:rPr>
+              <a:t>한계</a:t>
             </a:r>
             <a:endParaRPr lang="en-US" sz="900" dirty="0"/>
           </a:p>
@@ -1229,8 +1229,8 @@
         </p:nvSpPr>
         <p:spPr>
           <a:xfrm>
-            <a:off x="517475" y="2132707"/>
-            <a:ext cx="1761845" cy="228600"/>
+            <a:off x="517475" y="2189857"/>
+            <a:ext cx="1761845" cy="133350"/>
           </a:xfrm>
           <a:prstGeom prst="rect">
             <a:avLst/>
@@ -1256,11 +1256,11 @@
                 <a:solidFill>
                   <a:srgbClr val="333333"/>
                 </a:solidFill>
-                <a:latin typeface="Times New Roman" pitchFamily="34" charset="0"/>
-                <a:ea typeface="Times New Roman" pitchFamily="34" charset="-122"/>
-                <a:cs typeface="Times New Roman" pitchFamily="34" charset="-120"/>
-              </a:rPr>
-              <a:t>Convoy effect; no service differentiation</a:t>
+                <a:latin typeface="Malgun Gothic" pitchFamily="34" charset="0"/>
+                <a:ea typeface="Malgun Gothic" pitchFamily="34" charset="-122"/>
+                <a:cs typeface="Malgun Gothic" pitchFamily="34" charset="-120"/>
+              </a:rPr>
+              <a:t>호위 효과 발생, 차등 서비스 불가</a:t>
             </a:r>
             <a:endParaRPr lang="en-US" sz="850" dirty="0"/>
           </a:p>
@@ -1275,7 +1275,7 @@
         <p:spPr>
           <a:xfrm>
             <a:off x="2508200" y="304800"/>
-            <a:ext cx="2000399" cy="3556695"/>
+            <a:ext cx="2000399" cy="3518595"/>
           </a:xfrm>
           <a:prstGeom prst="rect">
             <a:avLst/>
@@ -1357,9 +1357,9 @@
                 <a:solidFill>
                   <a:srgbClr val="FFFFFF"/>
                 </a:solidFill>
-                <a:latin typeface="Times New Roman" pitchFamily="34" charset="0"/>
-                <a:ea typeface="Times New Roman" pitchFamily="34" charset="-122"/>
-                <a:cs typeface="Times New Roman" pitchFamily="34" charset="-120"/>
+                <a:latin typeface="Malgun Gothic" pitchFamily="34" charset="0"/>
+                <a:ea typeface="Malgun Gothic" pitchFamily="34" charset="-122"/>
+                <a:cs typeface="Malgun Gothic" pitchFamily="34" charset="-120"/>
               </a:rPr>
               <a:t>Priority</a:t>
             </a:r>
@@ -1402,11 +1402,11 @@
                 <a:solidFill>
                   <a:srgbClr val="555555"/>
                 </a:solidFill>
-                <a:latin typeface="Times New Roman" pitchFamily="34" charset="0"/>
-                <a:ea typeface="Times New Roman" pitchFamily="34" charset="-122"/>
-                <a:cs typeface="Times New Roman" pitchFamily="34" charset="-120"/>
-              </a:rPr>
-              <a:t>Priority-based + Aging</a:t>
+                <a:latin typeface="Malgun Gothic" pitchFamily="34" charset="0"/>
+                <a:ea typeface="Malgun Gothic" pitchFamily="34" charset="-122"/>
+                <a:cs typeface="Malgun Gothic" pitchFamily="34" charset="-120"/>
+              </a:rPr>
+              <a:t>우선순위 기반 + 에이징</a:t>
             </a:r>
             <a:endParaRPr lang="en-US" sz="900" dirty="0"/>
           </a:p>
@@ -1464,11 +1464,11 @@
                 <a:solidFill>
                   <a:srgbClr val="333333"/>
                 </a:solidFill>
-                <a:latin typeface="Times New Roman" pitchFamily="34" charset="0"/>
-                <a:ea typeface="Times New Roman" pitchFamily="34" charset="-122"/>
-                <a:cs typeface="Times New Roman" pitchFamily="34" charset="-120"/>
-              </a:rPr>
-              <a:t>Characteristics</a:t>
+                <a:latin typeface="Malgun Gothic" pitchFamily="34" charset="0"/>
+                <a:ea typeface="Malgun Gothic" pitchFamily="34" charset="-122"/>
+                <a:cs typeface="Malgun Gothic" pitchFamily="34" charset="-120"/>
+              </a:rPr>
+              <a:t>특징</a:t>
             </a:r>
             <a:endParaRPr lang="en-US" sz="900" dirty="0"/>
           </a:p>
@@ -1483,7 +1483,7 @@
         <p:spPr>
           <a:xfrm>
             <a:off x="2644676" y="1383804"/>
-            <a:ext cx="1727448" cy="342900"/>
+            <a:ext cx="1727448" cy="400050"/>
           </a:xfrm>
           <a:prstGeom prst="rect">
             <a:avLst/>
@@ -1504,11 +1504,11 @@
                 <a:solidFill>
                   <a:srgbClr val="333333"/>
                 </a:solidFill>
-                <a:latin typeface="Times New Roman" pitchFamily="34" charset="0"/>
-                <a:ea typeface="Times New Roman" pitchFamily="34" charset="-122"/>
-                <a:cs typeface="Times New Roman" pitchFamily="34" charset="-120"/>
-              </a:rPr>
-              <a:t>4-level priority (URGENT~LOW)</a:t>
+                <a:latin typeface="Malgun Gothic" pitchFamily="34" charset="0"/>
+                <a:ea typeface="Malgun Gothic" pitchFamily="34" charset="-122"/>
+                <a:cs typeface="Malgun Gothic" pitchFamily="34" charset="-120"/>
+              </a:rPr>
+              <a:t>4단계 우선순위 (URGENT~LOW)</a:t>
             </a:r>
             <a:endParaRPr lang="en-US" sz="850" dirty="0"/>
           </a:p>
@@ -1522,11 +1522,11 @@
                 <a:solidFill>
                   <a:srgbClr val="333333"/>
                 </a:solidFill>
-                <a:latin typeface="Times New Roman" pitchFamily="34" charset="0"/>
-                <a:ea typeface="Times New Roman" pitchFamily="34" charset="-122"/>
-                <a:cs typeface="Times New Roman" pitchFamily="34" charset="-120"/>
-              </a:rPr>
-              <a:t>Aging for starvation prevention</a:t>
+                <a:latin typeface="Malgun Gothic" pitchFamily="34" charset="0"/>
+                <a:ea typeface="Malgun Gothic" pitchFamily="34" charset="-122"/>
+                <a:cs typeface="Malgun Gothic" pitchFamily="34" charset="-120"/>
+              </a:rPr>
+              <a:t>에이징으로 기아 방지</a:t>
             </a:r>
             <a:endParaRPr lang="en-US" sz="850" dirty="0"/>
           </a:p>
@@ -1540,11 +1540,11 @@
                 <a:solidFill>
                   <a:srgbClr val="333333"/>
                 </a:solidFill>
-                <a:latin typeface="Times New Roman" pitchFamily="34" charset="0"/>
-                <a:ea typeface="Times New Roman" pitchFamily="34" charset="-122"/>
-                <a:cs typeface="Times New Roman" pitchFamily="34" charset="-120"/>
-              </a:rPr>
-              <a:t>Dynamic priority adjustment</a:t>
+                <a:latin typeface="Malgun Gothic" pitchFamily="34" charset="0"/>
+                <a:ea typeface="Malgun Gothic" pitchFamily="34" charset="-122"/>
+                <a:cs typeface="Malgun Gothic" pitchFamily="34" charset="-120"/>
+              </a:rPr>
+              <a:t>동적 우선순위 조정</a:t>
             </a:r>
             <a:endParaRPr lang="en-US" sz="850" dirty="0"/>
           </a:p>
@@ -1558,7 +1558,7 @@
         </p:nvSpPr>
         <p:spPr>
           <a:xfrm>
-            <a:off x="2644676" y="2039243"/>
+            <a:off x="2644676" y="2096393"/>
             <a:ext cx="1727448" cy="0"/>
           </a:xfrm>
           <a:prstGeom prst="line">
@@ -1581,7 +1581,7 @@
         </p:nvSpPr>
         <p:spPr>
           <a:xfrm>
-            <a:off x="2644676" y="1853505"/>
+            <a:off x="2644676" y="1910655"/>
             <a:ext cx="1761997" cy="142875"/>
           </a:xfrm>
           <a:prstGeom prst="rect">
@@ -1602,11 +1602,11 @@
                 <a:solidFill>
                   <a:srgbClr val="333333"/>
                 </a:solidFill>
-                <a:latin typeface="Times New Roman" pitchFamily="34" charset="0"/>
-                <a:ea typeface="Times New Roman" pitchFamily="34" charset="-122"/>
-                <a:cs typeface="Times New Roman" pitchFamily="34" charset="-120"/>
-              </a:rPr>
-              <a:t>Limitation</a:t>
+                <a:latin typeface="Malgun Gothic" pitchFamily="34" charset="0"/>
+                <a:ea typeface="Malgun Gothic" pitchFamily="34" charset="-122"/>
+                <a:cs typeface="Malgun Gothic" pitchFamily="34" charset="-120"/>
+              </a:rPr>
+              <a:t>한계</a:t>
             </a:r>
             <a:endParaRPr lang="en-US" sz="900" dirty="0"/>
           </a:p>
@@ -1620,8 +1620,8 @@
         </p:nvSpPr>
         <p:spPr>
           <a:xfrm>
-            <a:off x="2644676" y="2132707"/>
-            <a:ext cx="1761997" cy="114300"/>
+            <a:off x="2644676" y="2189857"/>
+            <a:ext cx="1761997" cy="133350"/>
           </a:xfrm>
           <a:prstGeom prst="rect">
             <a:avLst/>
@@ -1647,11 +1647,11 @@
                 <a:solidFill>
                   <a:srgbClr val="333333"/>
                 </a:solidFill>
-                <a:latin typeface="Times New Roman" pitchFamily="34" charset="0"/>
-                <a:ea typeface="Times New Roman" pitchFamily="34" charset="-122"/>
-                <a:cs typeface="Times New Roman" pitchFamily="34" charset="-120"/>
-              </a:rPr>
-              <a:t>Potential starvation without aging</a:t>
+                <a:latin typeface="Malgun Gothic" pitchFamily="34" charset="0"/>
+                <a:ea typeface="Malgun Gothic" pitchFamily="34" charset="-122"/>
+                <a:cs typeface="Malgun Gothic" pitchFamily="34" charset="-120"/>
+              </a:rPr>
+              <a:t>에이징 없으면 기아 발생 가능</a:t>
             </a:r>
             <a:endParaRPr lang="en-US" sz="850" dirty="0"/>
           </a:p>
@@ -1666,7 +1666,7 @@
         <p:spPr>
           <a:xfrm>
             <a:off x="4635550" y="304800"/>
-            <a:ext cx="2000250" cy="3556695"/>
+            <a:ext cx="2000250" cy="3518595"/>
           </a:xfrm>
           <a:prstGeom prst="rect">
             <a:avLst/>
@@ -1748,9 +1748,9 @@
                 <a:solidFill>
                   <a:srgbClr val="FFFFFF"/>
                 </a:solidFill>
-                <a:latin typeface="Times New Roman" pitchFamily="34" charset="0"/>
-                <a:ea typeface="Times New Roman" pitchFamily="34" charset="-122"/>
-                <a:cs typeface="Times New Roman" pitchFamily="34" charset="-120"/>
+                <a:latin typeface="Malgun Gothic" pitchFamily="34" charset="0"/>
+                <a:ea typeface="Malgun Gothic" pitchFamily="34" charset="-122"/>
+                <a:cs typeface="Malgun Gothic" pitchFamily="34" charset="-120"/>
               </a:rPr>
               <a:t>MLFQ</a:t>
             </a:r>
@@ -1793,11 +1793,11 @@
                 <a:solidFill>
                   <a:srgbClr val="555555"/>
                 </a:solidFill>
-                <a:latin typeface="Times New Roman" pitchFamily="34" charset="0"/>
-                <a:ea typeface="Times New Roman" pitchFamily="34" charset="-122"/>
-                <a:cs typeface="Times New Roman" pitchFamily="34" charset="-120"/>
-              </a:rPr>
-              <a:t>Multi-Level Feedback Queue</a:t>
+                <a:latin typeface="Malgun Gothic" pitchFamily="34" charset="0"/>
+                <a:ea typeface="Malgun Gothic" pitchFamily="34" charset="-122"/>
+                <a:cs typeface="Malgun Gothic" pitchFamily="34" charset="-120"/>
+              </a:rPr>
+              <a:t>다단계 피드백 큐</a:t>
             </a:r>
             <a:endParaRPr lang="en-US" sz="900" dirty="0"/>
           </a:p>
@@ -1855,11 +1855,11 @@
                 <a:solidFill>
                   <a:srgbClr val="333333"/>
                 </a:solidFill>
-                <a:latin typeface="Times New Roman" pitchFamily="34" charset="0"/>
-                <a:ea typeface="Times New Roman" pitchFamily="34" charset="-122"/>
-                <a:cs typeface="Times New Roman" pitchFamily="34" charset="-120"/>
-              </a:rPr>
-              <a:t>Characteristics</a:t>
+                <a:latin typeface="Malgun Gothic" pitchFamily="34" charset="0"/>
+                <a:ea typeface="Malgun Gothic" pitchFamily="34" charset="-122"/>
+                <a:cs typeface="Malgun Gothic" pitchFamily="34" charset="-120"/>
+              </a:rPr>
+              <a:t>특징</a:t>
             </a:r>
             <a:endParaRPr lang="en-US" sz="900" dirty="0"/>
           </a:p>
@@ -1874,7 +1874,7 @@
         <p:spPr>
           <a:xfrm>
             <a:off x="4772025" y="1383804"/>
-            <a:ext cx="1727299" cy="342900"/>
+            <a:ext cx="1727299" cy="400050"/>
           </a:xfrm>
           <a:prstGeom prst="rect">
             <a:avLst/>
@@ -1895,11 +1895,11 @@
                 <a:solidFill>
                   <a:srgbClr val="333333"/>
                 </a:solidFill>
-                <a:latin typeface="Times New Roman" pitchFamily="34" charset="0"/>
-                <a:ea typeface="Times New Roman" pitchFamily="34" charset="-122"/>
-                <a:cs typeface="Times New Roman" pitchFamily="34" charset="-120"/>
-              </a:rPr>
-              <a:t>Adaptive classification</a:t>
+                <a:latin typeface="Malgun Gothic" pitchFamily="34" charset="0"/>
+                <a:ea typeface="Malgun Gothic" pitchFamily="34" charset="-122"/>
+                <a:cs typeface="Malgun Gothic" pitchFamily="34" charset="-120"/>
+              </a:rPr>
+              <a:t>적응형 분류</a:t>
             </a:r>
             <a:endParaRPr lang="en-US" sz="850" dirty="0"/>
           </a:p>
@@ -1913,11 +1913,11 @@
                 <a:solidFill>
                   <a:srgbClr val="333333"/>
                 </a:solidFill>
-                <a:latin typeface="Times New Roman" pitchFamily="34" charset="0"/>
-                <a:ea typeface="Times New Roman" pitchFamily="34" charset="-122"/>
-                <a:cs typeface="Times New Roman" pitchFamily="34" charset="-120"/>
-              </a:rPr>
-              <a:t>Time quantum per level</a:t>
+                <a:latin typeface="Malgun Gothic" pitchFamily="34" charset="0"/>
+                <a:ea typeface="Malgun Gothic" pitchFamily="34" charset="-122"/>
+                <a:cs typeface="Malgun Gothic" pitchFamily="34" charset="-120"/>
+              </a:rPr>
+              <a:t>큐별 타임 퀀텀</a:t>
             </a:r>
             <a:endParaRPr lang="en-US" sz="850" dirty="0"/>
           </a:p>
@@ -1931,11 +1931,11 @@
                 <a:solidFill>
                   <a:srgbClr val="333333"/>
                 </a:solidFill>
-                <a:latin typeface="Times New Roman" pitchFamily="34" charset="0"/>
-                <a:ea typeface="Times New Roman" pitchFamily="34" charset="-122"/>
-                <a:cs typeface="Times New Roman" pitchFamily="34" charset="-120"/>
-              </a:rPr>
-              <a:t>Preemptive scheduling</a:t>
+                <a:latin typeface="Malgun Gothic" pitchFamily="34" charset="0"/>
+                <a:ea typeface="Malgun Gothic" pitchFamily="34" charset="-122"/>
+                <a:cs typeface="Malgun Gothic" pitchFamily="34" charset="-120"/>
+              </a:rPr>
+              <a:t>선점형 스케줄링</a:t>
             </a:r>
             <a:endParaRPr lang="en-US" sz="850" dirty="0"/>
           </a:p>
@@ -1949,7 +1949,7 @@
         </p:nvSpPr>
         <p:spPr>
           <a:xfrm>
-            <a:off x="4772025" y="2039243"/>
+            <a:off x="4772025" y="2096393"/>
             <a:ext cx="1727299" cy="0"/>
           </a:xfrm>
           <a:prstGeom prst="line">
@@ -1972,7 +1972,7 @@
         </p:nvSpPr>
         <p:spPr>
           <a:xfrm>
-            <a:off x="4772025" y="1853505"/>
+            <a:off x="4772025" y="1910655"/>
             <a:ext cx="1761845" cy="142875"/>
           </a:xfrm>
           <a:prstGeom prst="rect">
@@ -1993,11 +1993,11 @@
                 <a:solidFill>
                   <a:srgbClr val="333333"/>
                 </a:solidFill>
-                <a:latin typeface="Times New Roman" pitchFamily="34" charset="0"/>
-                <a:ea typeface="Times New Roman" pitchFamily="34" charset="-122"/>
-                <a:cs typeface="Times New Roman" pitchFamily="34" charset="-120"/>
-              </a:rPr>
-              <a:t>Limitation</a:t>
+                <a:latin typeface="Malgun Gothic" pitchFamily="34" charset="0"/>
+                <a:ea typeface="Malgun Gothic" pitchFamily="34" charset="-122"/>
+                <a:cs typeface="Malgun Gothic" pitchFamily="34" charset="-120"/>
+              </a:rPr>
+              <a:t>한계</a:t>
             </a:r>
             <a:endParaRPr lang="en-US" sz="900" dirty="0"/>
           </a:p>
@@ -2011,8 +2011,8 @@
         </p:nvSpPr>
         <p:spPr>
           <a:xfrm>
-            <a:off x="4772025" y="2132707"/>
-            <a:ext cx="1761845" cy="114300"/>
+            <a:off x="4772025" y="2189857"/>
+            <a:ext cx="1761845" cy="133350"/>
           </a:xfrm>
           <a:prstGeom prst="rect">
             <a:avLst/>
@@ -2038,11 +2038,11 @@
                 <a:solidFill>
                   <a:srgbClr val="333333"/>
                 </a:solidFill>
-                <a:latin typeface="Times New Roman" pitchFamily="34" charset="0"/>
-                <a:ea typeface="Times New Roman" pitchFamily="34" charset="-122"/>
-                <a:cs typeface="Times New Roman" pitchFamily="34" charset="-120"/>
-              </a:rPr>
-              <a:t>Parameter tuning complexity</a:t>
+                <a:latin typeface="Malgun Gothic" pitchFamily="34" charset="0"/>
+                <a:ea typeface="Malgun Gothic" pitchFamily="34" charset="-122"/>
+                <a:cs typeface="Malgun Gothic" pitchFamily="34" charset="-120"/>
+              </a:rPr>
+              <a:t>파라미터 튜닝 복잡</a:t>
             </a:r>
             <a:endParaRPr lang="en-US" sz="850" dirty="0"/>
           </a:p>
@@ -2057,7 +2057,7 @@
         <p:spPr>
           <a:xfrm>
             <a:off x="6762750" y="304800"/>
-            <a:ext cx="2000250" cy="3556695"/>
+            <a:ext cx="2000250" cy="3518595"/>
           </a:xfrm>
           <a:prstGeom prst="rect">
             <a:avLst/>
@@ -2139,9 +2139,9 @@
                 <a:solidFill>
                   <a:srgbClr val="FFFFFF"/>
                 </a:solidFill>
-                <a:latin typeface="Times New Roman" pitchFamily="34" charset="0"/>
-                <a:ea typeface="Times New Roman" pitchFamily="34" charset="-122"/>
-                <a:cs typeface="Times New Roman" pitchFamily="34" charset="-120"/>
+                <a:latin typeface="Malgun Gothic" pitchFamily="34" charset="0"/>
+                <a:ea typeface="Malgun Gothic" pitchFamily="34" charset="-122"/>
+                <a:cs typeface="Malgun Gothic" pitchFamily="34" charset="-120"/>
               </a:rPr>
               <a:t>WFQ</a:t>
             </a:r>
@@ -2184,11 +2184,11 @@
                 <a:solidFill>
                   <a:srgbClr val="555555"/>
                 </a:solidFill>
-                <a:latin typeface="Times New Roman" pitchFamily="34" charset="0"/>
-                <a:ea typeface="Times New Roman" pitchFamily="34" charset="-122"/>
-                <a:cs typeface="Times New Roman" pitchFamily="34" charset="-120"/>
-              </a:rPr>
-              <a:t>Weighted Fair Queuing</a:t>
+                <a:latin typeface="Malgun Gothic" pitchFamily="34" charset="0"/>
+                <a:ea typeface="Malgun Gothic" pitchFamily="34" charset="-122"/>
+                <a:cs typeface="Malgun Gothic" pitchFamily="34" charset="-120"/>
+              </a:rPr>
+              <a:t>가중치 공정 큐잉</a:t>
             </a:r>
             <a:endParaRPr lang="en-US" sz="900" dirty="0"/>
           </a:p>
@@ -2246,11 +2246,11 @@
                 <a:solidFill>
                   <a:srgbClr val="333333"/>
                 </a:solidFill>
-                <a:latin typeface="Times New Roman" pitchFamily="34" charset="0"/>
-                <a:ea typeface="Times New Roman" pitchFamily="34" charset="-122"/>
-                <a:cs typeface="Times New Roman" pitchFamily="34" charset="-120"/>
-              </a:rPr>
-              <a:t>Characteristics</a:t>
+                <a:latin typeface="Malgun Gothic" pitchFamily="34" charset="0"/>
+                <a:ea typeface="Malgun Gothic" pitchFamily="34" charset="-122"/>
+                <a:cs typeface="Malgun Gothic" pitchFamily="34" charset="-120"/>
+              </a:rPr>
+              <a:t>특징</a:t>
             </a:r>
             <a:endParaRPr lang="en-US" sz="900" dirty="0"/>
           </a:p>
@@ -2265,7 +2265,7 @@
         <p:spPr>
           <a:xfrm>
             <a:off x="6899225" y="1383804"/>
-            <a:ext cx="1727299" cy="342900"/>
+            <a:ext cx="1727299" cy="400050"/>
           </a:xfrm>
           <a:prstGeom prst="rect">
             <a:avLst/>
@@ -2286,11 +2286,11 @@
                 <a:solidFill>
                   <a:srgbClr val="333333"/>
                 </a:solidFill>
-                <a:latin typeface="Times New Roman" pitchFamily="34" charset="0"/>
-                <a:ea typeface="Times New Roman" pitchFamily="34" charset="-122"/>
-                <a:cs typeface="Times New Roman" pitchFamily="34" charset="-120"/>
-              </a:rPr>
-              <a:t>Weight-proportional service</a:t>
+                <a:latin typeface="Malgun Gothic" pitchFamily="34" charset="0"/>
+                <a:ea typeface="Malgun Gothic" pitchFamily="34" charset="-122"/>
+                <a:cs typeface="Malgun Gothic" pitchFamily="34" charset="-120"/>
+              </a:rPr>
+              <a:t>가중치 비례 서비스</a:t>
             </a:r>
             <a:endParaRPr lang="en-US" sz="850" dirty="0"/>
           </a:p>
@@ -2304,11 +2304,11 @@
                 <a:solidFill>
                   <a:srgbClr val="333333"/>
                 </a:solidFill>
-                <a:latin typeface="Times New Roman" pitchFamily="34" charset="0"/>
-                <a:ea typeface="Times New Roman" pitchFamily="34" charset="-122"/>
-                <a:cs typeface="Times New Roman" pitchFamily="34" charset="-120"/>
-              </a:rPr>
-              <a:t>Virtual Finish Time</a:t>
+                <a:latin typeface="Malgun Gothic" pitchFamily="34" charset="0"/>
+                <a:ea typeface="Malgun Gothic" pitchFamily="34" charset="-122"/>
+                <a:cs typeface="Malgun Gothic" pitchFamily="34" charset="-120"/>
+              </a:rPr>
+              <a:t>가상 종료 시각 계산</a:t>
             </a:r>
             <a:endParaRPr lang="en-US" sz="850" dirty="0"/>
           </a:p>
@@ -2322,11 +2322,11 @@
                 <a:solidFill>
                   <a:srgbClr val="333333"/>
                 </a:solidFill>
-                <a:latin typeface="Times New Roman" pitchFamily="34" charset="0"/>
-                <a:ea typeface="Times New Roman" pitchFamily="34" charset="-122"/>
-                <a:cs typeface="Times New Roman" pitchFamily="34" charset="-120"/>
-              </a:rPr>
-              <a:t>JFI fairness metric</a:t>
+                <a:latin typeface="Malgun Gothic" pitchFamily="34" charset="0"/>
+                <a:ea typeface="Malgun Gothic" pitchFamily="34" charset="-122"/>
+                <a:cs typeface="Malgun Gothic" pitchFamily="34" charset="-120"/>
+              </a:rPr>
+              <a:t>JFI 공정성 지표</a:t>
             </a:r>
             <a:endParaRPr lang="en-US" sz="850" dirty="0"/>
           </a:p>
@@ -2340,7 +2340,7 @@
         </p:nvSpPr>
         <p:spPr>
           <a:xfrm>
-            <a:off x="6899225" y="2039243"/>
+            <a:off x="6899225" y="2096393"/>
             <a:ext cx="1727299" cy="0"/>
           </a:xfrm>
           <a:prstGeom prst="line">
@@ -2363,7 +2363,7 @@
         </p:nvSpPr>
         <p:spPr>
           <a:xfrm>
-            <a:off x="6899225" y="1853505"/>
+            <a:off x="6899225" y="1910655"/>
             <a:ext cx="1761845" cy="142875"/>
           </a:xfrm>
           <a:prstGeom prst="rect">
@@ -2384,11 +2384,11 @@
                 <a:solidFill>
                   <a:srgbClr val="333333"/>
                 </a:solidFill>
-                <a:latin typeface="Times New Roman" pitchFamily="34" charset="0"/>
-                <a:ea typeface="Times New Roman" pitchFamily="34" charset="-122"/>
-                <a:cs typeface="Times New Roman" pitchFamily="34" charset="-120"/>
-              </a:rPr>
-              <a:t>Limitation</a:t>
+                <a:latin typeface="Malgun Gothic" pitchFamily="34" charset="0"/>
+                <a:ea typeface="Malgun Gothic" pitchFamily="34" charset="-122"/>
+                <a:cs typeface="Malgun Gothic" pitchFamily="34" charset="-120"/>
+              </a:rPr>
+              <a:t>한계</a:t>
             </a:r>
             <a:endParaRPr lang="en-US" sz="900" dirty="0"/>
           </a:p>
@@ -2402,8 +2402,8 @@
         </p:nvSpPr>
         <p:spPr>
           <a:xfrm>
-            <a:off x="6899225" y="2132707"/>
-            <a:ext cx="1761845" cy="114300"/>
+            <a:off x="6899225" y="2189857"/>
+            <a:ext cx="1761845" cy="133350"/>
           </a:xfrm>
           <a:prstGeom prst="rect">
             <a:avLst/>
@@ -2429,11 +2429,11 @@
                 <a:solidFill>
                   <a:srgbClr val="333333"/>
                 </a:solidFill>
-                <a:latin typeface="Times New Roman" pitchFamily="34" charset="0"/>
-                <a:ea typeface="Times New Roman" pitchFamily="34" charset="-122"/>
-                <a:cs typeface="Times New Roman" pitchFamily="34" charset="-120"/>
-              </a:rPr>
-              <a:t>Computational overhead of VFT</a:t>
+                <a:latin typeface="Malgun Gothic" pitchFamily="34" charset="0"/>
+                <a:ea typeface="Malgun Gothic" pitchFamily="34" charset="-122"/>
+                <a:cs typeface="Malgun Gothic" pitchFamily="34" charset="-120"/>
+              </a:rPr>
+              <a:t>VFT 계산 부담</a:t>
             </a:r>
             <a:endParaRPr lang="en-US" sz="850" dirty="0"/>
           </a:p>
@@ -2447,8 +2447,8 @@
         </p:nvSpPr>
         <p:spPr>
           <a:xfrm>
-            <a:off x="381000" y="3937695"/>
-            <a:ext cx="8401050" cy="558403"/>
+            <a:off x="381000" y="3899595"/>
+            <a:ext cx="8401050" cy="577453"/>
           </a:xfrm>
           <a:prstGeom prst="rect">
             <a:avLst/>
@@ -2479,7 +2479,7 @@
         </p:nvSpPr>
         <p:spPr>
           <a:xfrm>
-            <a:off x="390525" y="3947220"/>
+            <a:off x="390525" y="3909120"/>
             <a:ext cx="8382000" cy="298252"/>
           </a:xfrm>
           <a:prstGeom prst="rect">
@@ -2509,8 +2509,8 @@
         </p:nvSpPr>
         <p:spPr>
           <a:xfrm>
-            <a:off x="517475" y="4010620"/>
-            <a:ext cx="858911" cy="171450"/>
+            <a:off x="517475" y="3972520"/>
+            <a:ext cx="898380" cy="171450"/>
           </a:xfrm>
           <a:prstGeom prst="rect">
             <a:avLst/>
@@ -2530,9 +2530,9 @@
                 <a:solidFill>
                   <a:srgbClr val="FFFFFF"/>
                 </a:solidFill>
-                <a:latin typeface="Times New Roman" pitchFamily="34" charset="0"/>
-                <a:ea typeface="Times New Roman" pitchFamily="34" charset="-122"/>
-                <a:cs typeface="Times New Roman" pitchFamily="34" charset="-120"/>
+                <a:latin typeface="Malgun Gothic" pitchFamily="34" charset="0"/>
+                <a:ea typeface="Malgun Gothic" pitchFamily="34" charset="-122"/>
+                <a:cs typeface="Malgun Gothic" pitchFamily="34" charset="-120"/>
               </a:rPr>
               <a:t>Rate Limiter</a:t>
             </a:r>
@@ -2548,8 +2548,8 @@
         </p:nvSpPr>
         <p:spPr>
           <a:xfrm>
-            <a:off x="1511945" y="4039195"/>
-            <a:ext cx="1092994" cy="114300"/>
+            <a:off x="1550640" y="3991570"/>
+            <a:ext cx="822933" cy="133350"/>
           </a:xfrm>
           <a:prstGeom prst="rect">
             <a:avLst/>
@@ -2569,11 +2569,11 @@
                 <a:solidFill>
                   <a:srgbClr val="DDDDDD"/>
                 </a:solidFill>
-                <a:latin typeface="Times New Roman" pitchFamily="34" charset="0"/>
-                <a:ea typeface="Times New Roman" pitchFamily="34" charset="-122"/>
-                <a:cs typeface="Times New Roman" pitchFamily="34" charset="-120"/>
-              </a:rPr>
-              <a:t>Token Bucket Algorithm</a:t>
+                <a:latin typeface="Malgun Gothic" pitchFamily="34" charset="0"/>
+                <a:ea typeface="Malgun Gothic" pitchFamily="34" charset="-122"/>
+                <a:cs typeface="Malgun Gothic" pitchFamily="34" charset="-120"/>
+              </a:rPr>
+              <a:t>토큰 버킷 알고리즘</a:t>
             </a:r>
             <a:endParaRPr lang="en-US" sz="850" dirty="0"/>
           </a:p>
@@ -2587,8 +2587,8 @@
         </p:nvSpPr>
         <p:spPr>
           <a:xfrm>
-            <a:off x="517475" y="4308872"/>
-            <a:ext cx="1880556" cy="114300"/>
+            <a:off x="517475" y="4270772"/>
+            <a:ext cx="1301725" cy="133350"/>
           </a:xfrm>
           <a:prstGeom prst="rect">
             <a:avLst/>
@@ -2608,11 +2608,11 @@
                 <a:solidFill>
                   <a:srgbClr val="333333"/>
                 </a:solidFill>
-                <a:latin typeface="Times New Roman" pitchFamily="34" charset="0"/>
-                <a:ea typeface="Times New Roman" pitchFamily="34" charset="-122"/>
-                <a:cs typeface="Times New Roman" pitchFamily="34" charset="-120"/>
-              </a:rPr>
-              <a:t>Role:</a:t>
+                <a:latin typeface="Malgun Gothic" pitchFamily="34" charset="0"/>
+                <a:ea typeface="Malgun Gothic" pitchFamily="34" charset="-122"/>
+                <a:cs typeface="Malgun Gothic" pitchFamily="34" charset="-120"/>
+              </a:rPr>
+              <a:t>역할:</a:t>
             </a:r>
             <a:pPr algn="l" indent="0" marL="0">
               <a:buNone/>
@@ -2622,11 +2622,11 @@
                 <a:solidFill>
                   <a:srgbClr val="333333"/>
                 </a:solidFill>
-                <a:latin typeface="Times New Roman" pitchFamily="34" charset="0"/>
-                <a:ea typeface="Times New Roman" pitchFamily="34" charset="-122"/>
-                <a:cs typeface="Times New Roman" pitchFamily="34" charset="-120"/>
-              </a:rPr>
-              <a:t> Per-tenant request frequency control</a:t>
+                <a:latin typeface="Malgun Gothic" pitchFamily="34" charset="0"/>
+                <a:ea typeface="Malgun Gothic" pitchFamily="34" charset="-122"/>
+                <a:cs typeface="Malgun Gothic" pitchFamily="34" charset="-120"/>
+              </a:rPr>
+              <a:t> 테넌트별 요청 빈도 제한</a:t>
             </a:r>
             <a:endParaRPr lang="en-US" sz="850" dirty="0"/>
           </a:p>
@@ -2640,8 +2640,8 @@
         </p:nvSpPr>
         <p:spPr>
           <a:xfrm>
-            <a:off x="2615059" y="4308872"/>
-            <a:ext cx="1715089" cy="114300"/>
+            <a:off x="2047577" y="4270772"/>
+            <a:ext cx="985364" cy="133350"/>
           </a:xfrm>
           <a:prstGeom prst="rect">
             <a:avLst/>
@@ -2661,11 +2661,11 @@
                 <a:solidFill>
                   <a:srgbClr val="333333"/>
                 </a:solidFill>
-                <a:latin typeface="Times New Roman" pitchFamily="34" charset="0"/>
-                <a:ea typeface="Times New Roman" pitchFamily="34" charset="-122"/>
-                <a:cs typeface="Times New Roman" pitchFamily="34" charset="-120"/>
-              </a:rPr>
-              <a:t>Mechanism:</a:t>
+                <a:latin typeface="Malgun Gothic" pitchFamily="34" charset="0"/>
+                <a:ea typeface="Malgun Gothic" pitchFamily="34" charset="-122"/>
+                <a:cs typeface="Malgun Gothic" pitchFamily="34" charset="-120"/>
+              </a:rPr>
+              <a:t>방법:</a:t>
             </a:r>
             <a:pPr algn="l" indent="0" marL="0">
               <a:buNone/>
@@ -2675,11 +2675,11 @@
                 <a:solidFill>
                   <a:srgbClr val="333333"/>
                 </a:solidFill>
-                <a:latin typeface="Times New Roman" pitchFamily="34" charset="0"/>
-                <a:ea typeface="Times New Roman" pitchFamily="34" charset="-122"/>
-                <a:cs typeface="Times New Roman" pitchFamily="34" charset="-120"/>
-              </a:rPr>
-              <a:t> Burst capacity regulation</a:t>
+                <a:latin typeface="Malgun Gothic" pitchFamily="34" charset="0"/>
+                <a:ea typeface="Malgun Gothic" pitchFamily="34" charset="-122"/>
+                <a:cs typeface="Malgun Gothic" pitchFamily="34" charset="-120"/>
+              </a:rPr>
+              <a:t> 버스트 용량 제어</a:t>
             </a:r>
             <a:endParaRPr lang="en-US" sz="850" dirty="0"/>
           </a:p>
@@ -2693,8 +2693,8 @@
         </p:nvSpPr>
         <p:spPr>
           <a:xfrm>
-            <a:off x="4550420" y="4308872"/>
-            <a:ext cx="1849437" cy="114300"/>
+            <a:off x="3267521" y="4270772"/>
+            <a:ext cx="1279714" cy="133350"/>
           </a:xfrm>
           <a:prstGeom prst="rect">
             <a:avLst/>
@@ -2714,11 +2714,11 @@
                 <a:solidFill>
                   <a:srgbClr val="333333"/>
                 </a:solidFill>
-                <a:latin typeface="Times New Roman" pitchFamily="34" charset="0"/>
-                <a:ea typeface="Times New Roman" pitchFamily="34" charset="-122"/>
-                <a:cs typeface="Times New Roman" pitchFamily="34" charset="-120"/>
-              </a:rPr>
-              <a:t>Purpose:</a:t>
+                <a:latin typeface="Malgun Gothic" pitchFamily="34" charset="0"/>
+                <a:ea typeface="Malgun Gothic" pitchFamily="34" charset="-122"/>
+                <a:cs typeface="Malgun Gothic" pitchFamily="34" charset="-120"/>
+              </a:rPr>
+              <a:t>목적:</a:t>
             </a:r>
             <a:pPr algn="l" indent="0" marL="0">
               <a:buNone/>
@@ -2728,11 +2728,11 @@
                 <a:solidFill>
                   <a:srgbClr val="333333"/>
                 </a:solidFill>
-                <a:latin typeface="Times New Roman" pitchFamily="34" charset="0"/>
-                <a:ea typeface="Times New Roman" pitchFamily="34" charset="-122"/>
-                <a:cs typeface="Times New Roman" pitchFamily="34" charset="-120"/>
-              </a:rPr>
-              <a:t> Overload prevention (auxiliary)</a:t>
+                <a:latin typeface="Malgun Gothic" pitchFamily="34" charset="0"/>
+                <a:ea typeface="Malgun Gothic" pitchFamily="34" charset="-122"/>
+                <a:cs typeface="Malgun Gothic" pitchFamily="34" charset="-120"/>
+              </a:rPr>
+              <a:t> 과부하 방지 (보조 수단)</a:t>
             </a:r>
             <a:endParaRPr lang="en-US" sz="850" dirty="0"/>
           </a:p>
@@ -2746,7 +2746,7 @@
         </p:nvSpPr>
         <p:spPr>
           <a:xfrm>
-            <a:off x="381000" y="4632573"/>
+            <a:off x="381000" y="4613523"/>
             <a:ext cx="8382000" cy="0"/>
           </a:xfrm>
           <a:prstGeom prst="line">
@@ -2769,8 +2769,8 @@
         </p:nvSpPr>
         <p:spPr>
           <a:xfrm>
-            <a:off x="381000" y="4680198"/>
-            <a:ext cx="281901" cy="104775"/>
+            <a:off x="381000" y="4661148"/>
+            <a:ext cx="179281" cy="123825"/>
           </a:xfrm>
           <a:prstGeom prst="rect">
             <a:avLst/>
@@ -2790,11 +2790,11 @@
                 <a:solidFill>
                   <a:srgbClr val="555555"/>
                 </a:solidFill>
-                <a:latin typeface="Times New Roman" pitchFamily="34" charset="0"/>
-                <a:ea typeface="Times New Roman" pitchFamily="34" charset="-122"/>
-                <a:cs typeface="Times New Roman" pitchFamily="34" charset="-120"/>
-              </a:rPr>
-              <a:t>Simple</a:t>
+                <a:latin typeface="Malgun Gothic" pitchFamily="34" charset="0"/>
+                <a:ea typeface="Malgun Gothic" pitchFamily="34" charset="-122"/>
+                <a:cs typeface="Malgun Gothic" pitchFamily="34" charset="-120"/>
+              </a:rPr>
+              <a:t>단순</a:t>
             </a:r>
             <a:endParaRPr lang="en-US" sz="800" dirty="0"/>
           </a:p>
@@ -2808,8 +2808,8 @@
         </p:nvSpPr>
         <p:spPr>
           <a:xfrm>
-            <a:off x="3312914" y="4680198"/>
-            <a:ext cx="2482310" cy="104775"/>
+            <a:off x="4012406" y="4661148"/>
+            <a:ext cx="1141571" cy="123825"/>
           </a:xfrm>
           <a:prstGeom prst="rect">
             <a:avLst/>
@@ -2829,11 +2829,11 @@
                 <a:solidFill>
                   <a:srgbClr val="555555"/>
                 </a:solidFill>
-                <a:latin typeface="Times New Roman" pitchFamily="34" charset="0"/>
-                <a:ea typeface="Times New Roman" pitchFamily="34" charset="-122"/>
-                <a:cs typeface="Times New Roman" pitchFamily="34" charset="-120"/>
-              </a:rPr>
-              <a:t>Implementation Complexity / Performance Optimization  →</a:t>
+                <a:latin typeface="Malgun Gothic" pitchFamily="34" charset="0"/>
+                <a:ea typeface="Malgun Gothic" pitchFamily="34" charset="-122"/>
+                <a:cs typeface="Malgun Gothic" pitchFamily="34" charset="-120"/>
+              </a:rPr>
+              <a:t>구현 복잡도 / 성능 최적화  →</a:t>
             </a:r>
             <a:endParaRPr lang="en-US" sz="800" dirty="0"/>
           </a:p>
@@ -2847,8 +2847,8 @@
         </p:nvSpPr>
         <p:spPr>
           <a:xfrm>
-            <a:off x="8401943" y="4680198"/>
-            <a:ext cx="368278" cy="104775"/>
+            <a:off x="8587234" y="4661148"/>
+            <a:ext cx="179281" cy="123825"/>
           </a:xfrm>
           <a:prstGeom prst="rect">
             <a:avLst/>
@@ -2868,11 +2868,11 @@
                 <a:solidFill>
                   <a:srgbClr val="555555"/>
                 </a:solidFill>
-                <a:latin typeface="Times New Roman" pitchFamily="34" charset="0"/>
-                <a:ea typeface="Times New Roman" pitchFamily="34" charset="-122"/>
-                <a:cs typeface="Times New Roman" pitchFamily="34" charset="-120"/>
-              </a:rPr>
-              <a:t>Complex</a:t>
+                <a:latin typeface="Malgun Gothic" pitchFamily="34" charset="0"/>
+                <a:ea typeface="Malgun Gothic" pitchFamily="34" charset="-122"/>
+                <a:cs typeface="Malgun Gothic" pitchFamily="34" charset="-120"/>
+              </a:rPr>
+              <a:t>복잡</a:t>
             </a:r>
             <a:endParaRPr lang="en-US" sz="800" dirty="0"/>
           </a:p>
@@ -2930,9 +2930,9 @@
                 <a:solidFill>
                   <a:srgbClr val="999999"/>
                 </a:solidFill>
-                <a:latin typeface="Times New Roman" pitchFamily="34" charset="0"/>
-                <a:ea typeface="Times New Roman" pitchFamily="34" charset="-122"/>
-                <a:cs typeface="Times New Roman" pitchFamily="34" charset="-120"/>
+                <a:latin typeface="Malgun Gothic" pitchFamily="34" charset="0"/>
+                <a:ea typeface="Malgun Gothic" pitchFamily="34" charset="-122"/>
+                <a:cs typeface="Malgun Gothic" pitchFamily="34" charset="-120"/>
               </a:rPr>
               <a:t>[1] Silberschatz et al., Operating System Concepts, 10th ed., 2018.  [2] Arpaci-Dusseau, OSTEP, v1.10, 2023.  [3] Kurose &amp; Ross, Computer Networking, 8th ed., 2021.</a:t>
             </a:r>

</xml_diff>